<commit_message>
Present all seven countries as country packs; add static site build
Removes the "live in production" framing for the UAE. All seven countries —
UAE, KSA, Qatar, Kuwait, Oman, Bahrain and Libya — now read as country packs,
and the explainer describes what a pack contains (milestones, authorities,
document checklist, mandatory fields, payment types, alert thresholds) rather
than contrasting live against designed. Applied to both the journey and the deck.

Adds journey/build-standalone.py, which wraps the artifact-authored journey in a
full HTML document with share metadata so it can be hosted anywhere, and emits
the result to site/ for GitHub Pages.

Co-Authored-By: Claude Opus 5 <noreply@anthropic.com>
Claude-Session: https://claude.ai/code/session_01QVxFLMr5QhjAe5cSM3jDsE
</commit_message>
<xml_diff>
--- a/deck/INK_IT_Visa_and_Permits_GCC.pptx
+++ b/deck/INK_IT_Visa_and_Permits_GCC.pptx
@@ -511,7 +511,7 @@
           <a:p>
             <a:r>
               <a:rPr lang="en-US" dirty="0"/>
-              <a:t>Opening frame. The pitch: this is not a concept — it is a live SAP BTP application running work permit, renewal and cancellation lifecycles in production in the UAE, with configured country packs for the rest of the GCC and Libya. Emphasise three words: owned, visible, reconciled.</a:t>
+              <a:t>Opening frame. The pitch: a pre-built SAP BTP application covering the work permit, renewal and cancellation lifecycles, with configured country packs across the GCC and Libya. Emphasise three words: owned, visible, reconciled.</a:t>
             </a:r>
             <a:endParaRPr lang="en-US" dirty="0"/>
           </a:p>
@@ -775,7 +775,7 @@
           <a:p>
             <a:r>
               <a:rPr lang="en-US" dirty="0"/>
-              <a:t>Anchor on the screenshot — this is a real system, not a mock-up. The five capability tiles are what makes it a governance tool rather than a tracker.</a:t>
+              <a:t>Anchor on the screenshot — this is the built application, not a mock-up. The five capability tiles are what makes it a governance tool rather than a tracker.</a:t>
             </a:r>
             <a:endParaRPr lang="en-US" dirty="0"/>
           </a:p>
@@ -1127,7 +1127,7 @@
           <a:p>
             <a:r>
               <a:rPr lang="en-US" dirty="0"/>
-              <a:t>The GCC-ready slide. Be straight about live versus pack — credibility here is worth more than an overclaim, and the honesty usually earns the follow-up meeting. For KSA note the three-authority split: Qiwa for labour, Muqeem for the Iqama, Absher as the employee-facing mirror.</a:t>
+              <a:t>The GCC-ready slide. The message is breadth from one engine: each pack is configuration, not a rebuild, which is why deployment is weeks rather than quarters. For KSA note the three-authority split: Qiwa for labour, Muqeem for the Iqama, Absher as the employee-facing mirror.</a:t>
             </a:r>
             <a:endParaRPr lang="en-US" dirty="0"/>
           </a:p>
@@ -1904,11 +1904,11 @@
             </a:avLst>
           </a:prstGeom>
           <a:solidFill>
-            <a:srgbClr val="12756F"/>
+            <a:srgbClr val="16304C"/>
           </a:solidFill>
           <a:ln w="9525">
             <a:solidFill>
-              <a:srgbClr val="20A098"/>
+              <a:srgbClr val="2C4A6A"/>
             </a:solidFill>
             <a:prstDash val="solid"/>
           </a:ln>
@@ -1941,7 +1941,7 @@
             <a:r>
               <a:rPr lang="en-US" sz="1150" b="1" dirty="0">
                 <a:solidFill>
-                  <a:srgbClr val="FFFFFF"/>
+                  <a:srgbClr val="BFD6EC"/>
                 </a:solidFill>
                 <a:latin typeface="Calibri" pitchFamily="34" charset="0"/>
                 <a:ea typeface="Calibri" pitchFamily="34" charset="-122"/>
@@ -4503,7 +4503,7 @@
                 <a:ea typeface="Calibri" pitchFamily="34" charset="-122"/>
                 <a:cs typeface="Calibri" pitchFamily="34" charset="-120"/>
               </a:rPr>
-              <a:t>Live in the UAE  ·  Country packs for KSA, Qatar, Kuwait, Oman, Bahrain and Libya  ·  Work permits, healthcare licences and any industry-grade permit</a:t>
+              <a:t>Country packs for the UAE, KSA, Qatar, Kuwait, Oman, Bahrain and Libya  ·  Work permits, healthcare licences and any industry-grade permit</a:t>
             </a:r>
             <a:endParaRPr lang="en-US" sz="1000" dirty="0"/>
           </a:p>
@@ -6027,7 +6027,7 @@
                 <a:ea typeface="Calibri" pitchFamily="34" charset="-122"/>
                 <a:cs typeface="Calibri" pitchFamily="34" charset="-120"/>
               </a:rPr>
-              <a:t>Three governed lifecycles, twenty-two milestones, one task inbox — running in production today.</a:t>
+              <a:t>Three governed lifecycles, twenty-two milestones, one task inbox.</a:t>
             </a:r>
             <a:endParaRPr lang="en-US" sz="1350" dirty="0"/>
           </a:p>
@@ -6607,7 +6607,7 @@
                 <a:ea typeface="Calibri" pitchFamily="34" charset="-122"/>
                 <a:cs typeface="Calibri" pitchFamily="34" charset="-120"/>
               </a:rPr>
-              <a:t>The home dashboard — running, completed and cancelled counts across all three lifecycles, over a live queue of initiated cases with priority, status and assigned agent.</a:t>
+              <a:t>The home dashboard — running, completed and cancelled counts across all three lifecycles, over a queue of initiated cases with priority, status and assigned agent.</a:t>
             </a:r>
             <a:endParaRPr lang="en-US" sz="1000" dirty="0"/>
           </a:p>
@@ -12331,11 +12331,11 @@
             </a:avLst>
           </a:prstGeom>
           <a:solidFill>
-            <a:srgbClr val="123A4E"/>
+            <a:srgbClr val="13314C"/>
           </a:solidFill>
           <a:ln w="9525">
             <a:solidFill>
-              <a:srgbClr val="12756F"/>
+              <a:srgbClr val="27415C"/>
             </a:solidFill>
             <a:prstDash val="solid"/>
           </a:ln>
@@ -12397,7 +12397,7 @@
             </a:avLst>
           </a:prstGeom>
           <a:solidFill>
-            <a:srgbClr val="17795E"/>
+            <a:srgbClr val="C9A227"/>
           </a:solidFill>
           <a:ln/>
         </p:spPr>
@@ -12429,13 +12429,13 @@
             <a:r>
               <a:rPr lang="en-US" sz="750" b="1" dirty="0">
                 <a:solidFill>
-                  <a:srgbClr val="FFFFFF"/>
-                </a:solidFill>
-                <a:latin typeface="Calibri" pitchFamily="34" charset="0"/>
-                <a:ea typeface="Calibri" pitchFamily="34" charset="-122"/>
-                <a:cs typeface="Calibri" pitchFamily="34" charset="-120"/>
-              </a:rPr>
-              <a:t>LIVE</a:t>
+                  <a:srgbClr val="0C1E33"/>
+                </a:solidFill>
+                <a:latin typeface="Calibri" pitchFamily="34" charset="0"/>
+                <a:ea typeface="Calibri" pitchFamily="34" charset="-122"/>
+                <a:cs typeface="Calibri" pitchFamily="34" charset="-120"/>
+              </a:rPr>
+              <a:t>PACK</a:t>
             </a:r>
             <a:endParaRPr lang="en-US" sz="750" dirty="0"/>
           </a:p>
@@ -12753,7 +12753,7 @@
             </a:avLst>
           </a:prstGeom>
           <a:solidFill>
-            <a:srgbClr val="16304C"/>
+            <a:srgbClr val="13314C"/>
           </a:solidFill>
           <a:ln w="9525">
             <a:solidFill>
@@ -13175,7 +13175,7 @@
             </a:avLst>
           </a:prstGeom>
           <a:solidFill>
-            <a:srgbClr val="16304C"/>
+            <a:srgbClr val="13314C"/>
           </a:solidFill>
           <a:ln w="9525">
             <a:solidFill>
@@ -13597,7 +13597,7 @@
             </a:avLst>
           </a:prstGeom>
           <a:solidFill>
-            <a:srgbClr val="16304C"/>
+            <a:srgbClr val="13314C"/>
           </a:solidFill>
           <a:ln w="9525">
             <a:solidFill>
@@ -13938,13 +13938,13 @@
             <a:r>
               <a:rPr lang="en-US" sz="950" b="1" dirty="0">
                 <a:solidFill>
-                  <a:srgbClr val="17795E"/>
-                </a:solidFill>
-                <a:latin typeface="Calibri" pitchFamily="34" charset="0"/>
-                <a:ea typeface="Calibri" pitchFamily="34" charset="-122"/>
-                <a:cs typeface="Calibri" pitchFamily="34" charset="-120"/>
-              </a:rPr>
-              <a:t>LIVE</a:t>
+                  <a:srgbClr val="C9A227"/>
+                </a:solidFill>
+                <a:latin typeface="Calibri" pitchFamily="34" charset="0"/>
+                <a:ea typeface="Calibri" pitchFamily="34" charset="-122"/>
+                <a:cs typeface="Calibri" pitchFamily="34" charset="-120"/>
+              </a:rPr>
+              <a:t>PACK</a:t>
             </a:r>
             <a:pPr indent="0" marL="0">
               <a:lnSpc>
@@ -13961,41 +13961,7 @@
                 <a:ea typeface="Calibri" pitchFamily="34" charset="-122"/>
                 <a:cs typeface="Calibri" pitchFamily="34" charset="-120"/>
               </a:rPr>
-              <a:t> = running in production today.   </a:t>
-            </a:r>
-            <a:pPr indent="0" marL="0">
-              <a:lnSpc>
-                <a:spcPts val="1300"/>
-              </a:lnSpc>
-              <a:buNone/>
-            </a:pPr>
-            <a:r>
-              <a:rPr lang="en-US" sz="950" b="1" dirty="0">
-                <a:solidFill>
-                  <a:srgbClr val="C9A227"/>
-                </a:solidFill>
-                <a:latin typeface="Calibri" pitchFamily="34" charset="0"/>
-                <a:ea typeface="Calibri" pitchFamily="34" charset="-122"/>
-                <a:cs typeface="Calibri" pitchFamily="34" charset="-120"/>
-              </a:rPr>
-              <a:t>PACK</a:t>
-            </a:r>
-            <a:pPr indent="0" marL="0">
-              <a:lnSpc>
-                <a:spcPts val="1300"/>
-              </a:lnSpc>
-              <a:buNone/>
-            </a:pPr>
-            <a:r>
-              <a:rPr lang="en-US" sz="950" dirty="0">
-                <a:solidFill>
-                  <a:srgbClr val="A9C2DA"/>
-                </a:solidFill>
-                <a:latin typeface="Calibri" pitchFamily="34" charset="0"/>
-                <a:ea typeface="Calibri" pitchFamily="34" charset="-122"/>
-                <a:cs typeface="Calibri" pitchFamily="34" charset="-120"/>
-              </a:rPr>
-              <a:t> = designed against that country’s statutory flow and configured from the same engine, with a localisation workshop confirming document names, fees and thresholds before go-live.</a:t>
+              <a:t> = the country’s statutory flow expressed as configuration on the shared engine — milestones, authorities, document checklist, mandatory fields, payment types and alert thresholds. Pre-built rather than custom-developed, with a localisation workshop confirming document names, fees and thresholds before go-live.</a:t>
             </a:r>
             <a:endParaRPr lang="en-US" sz="950" dirty="0"/>
           </a:p>
@@ -17620,7 +17586,7 @@
                 <a:ea typeface="Calibri" pitchFamily="34" charset="-122"/>
                 <a:cs typeface="Calibri" pitchFamily="34" charset="-120"/>
               </a:rPr>
-              <a:t>— and this is how the system runs in production today — the government step stays a tracked manual PRO activity, with reference number, receipt and status captured in the milestone.</a:t>
+              <a:t>the government step stays a tracked manual PRO activity, with reference number, receipt and status captured in the milestone — which is how the application is designed to operate from day one, with or without a portal connection.</a:t>
             </a:r>
             <a:endParaRPr lang="en-US" sz="840" dirty="0"/>
           </a:p>

</xml_diff>